<commit_message>
README.md and project presentation
</commit_message>
<xml_diff>
--- a/docs/OtusCourceProject.pptx
+++ b/docs/OtusCourceProject.pptx
@@ -3445,7 +3445,7 @@
                 <a:latin typeface="Liberation Sans"/>
                 <a:cs typeface="Liberation Sans"/>
               </a:rPr>
-              <a:t>«Мобильное приложение для мониторинга криптовалютного рынка»</a:t>
+              <a:t>«Кроссплатформенное приложение для мониторинга криптовалютного рынка»</a:t>
             </a:r>
             <a:endParaRPr sz="4800" b="0" strike="noStrike" spc="-1">
               <a:solidFill>
@@ -3679,7 +3679,7 @@
             <a:endParaRPr sz="3600" b="1"/>
           </a:p>
           <a:p>
-            <a:pPr marL="482138" indent="-482138">
+            <a:pPr marL="482137" indent="-482137">
               <a:buAutoNum type="arabicPeriod"/>
               <a:defRPr/>
             </a:pPr>
@@ -3690,7 +3690,7 @@
             <a:endParaRPr sz="3600"/>
           </a:p>
           <a:p>
-            <a:pPr marL="482138" indent="-482138">
+            <a:pPr marL="482137" indent="-482137">
               <a:buAutoNum type="arabicPeriod"/>
               <a:defRPr/>
             </a:pPr>
@@ -3701,7 +3701,7 @@
             <a:endParaRPr sz="3600"/>
           </a:p>
           <a:p>
-            <a:pPr marL="482138" indent="-482138">
+            <a:pPr marL="482137" indent="-482137">
               <a:buAutoNum type="arabicPeriod"/>
               <a:defRPr/>
             </a:pPr>
@@ -3712,7 +3712,7 @@
             <a:endParaRPr sz="3600"/>
           </a:p>
           <a:p>
-            <a:pPr marL="482138" indent="-482138">
+            <a:pPr marL="482137" indent="-482137">
               <a:buAutoNum type="arabicPeriod"/>
               <a:defRPr/>
             </a:pPr>
@@ -3723,7 +3723,7 @@
             <a:endParaRPr sz="3600"/>
           </a:p>
           <a:p>
-            <a:pPr marL="482138" indent="-482138">
+            <a:pPr marL="482137" indent="-482137">
               <a:buAutoNum type="arabicPeriod"/>
               <a:defRPr/>
             </a:pPr>
@@ -3812,7 +3812,7 @@
             <a:endParaRPr sz="3600" b="1"/>
           </a:p>
           <a:p>
-            <a:pPr marL="482138" indent="-482138">
+            <a:pPr marL="482137" indent="-482137">
               <a:buAutoNum type="arabicPeriod"/>
               <a:defRPr/>
             </a:pPr>
@@ -3823,7 +3823,7 @@
             <a:endParaRPr sz="2800"/>
           </a:p>
           <a:p>
-            <a:pPr marL="482138" indent="-482138">
+            <a:pPr marL="482137" indent="-482137">
               <a:buAutoNum type="arabicPeriod"/>
               <a:defRPr/>
             </a:pPr>
@@ -3834,7 +3834,7 @@
             <a:endParaRPr sz="2800"/>
           </a:p>
           <a:p>
-            <a:pPr marL="482138" indent="-482138">
+            <a:pPr marL="482137" indent="-482137">
               <a:buAutoNum type="arabicPeriod"/>
               <a:defRPr/>
             </a:pPr>
@@ -3845,7 +3845,7 @@
             <a:endParaRPr sz="2800"/>
           </a:p>
           <a:p>
-            <a:pPr marL="482138" indent="-482138">
+            <a:pPr marL="482137" indent="-482137">
               <a:buAutoNum type="arabicPeriod"/>
               <a:defRPr/>
             </a:pPr>
@@ -3856,7 +3856,7 @@
             <a:endParaRPr sz="2800"/>
           </a:p>
           <a:p>
-            <a:pPr marL="482138" indent="-482138">
+            <a:pPr marL="482137" indent="-482137">
               <a:buAutoNum type="arabicPeriod"/>
               <a:defRPr/>
             </a:pPr>
@@ -3945,7 +3945,7 @@
             <a:endParaRPr sz="3600" b="1"/>
           </a:p>
           <a:p>
-            <a:pPr marL="482138" indent="-482138">
+            <a:pPr marL="482137" indent="-482137">
               <a:buAutoNum type="arabicPeriod"/>
               <a:defRPr/>
             </a:pPr>
@@ -3956,7 +3956,7 @@
             <a:endParaRPr sz="3600"/>
           </a:p>
           <a:p>
-            <a:pPr marL="882188" lvl="1" indent="-482138">
+            <a:pPr marL="882187" lvl="1" indent="-482137">
               <a:buAutoNum type="arabicPeriod"/>
               <a:defRPr/>
             </a:pPr>
@@ -3967,7 +3967,7 @@
             <a:endParaRPr sz="3600"/>
           </a:p>
           <a:p>
-            <a:pPr marL="882188" lvl="1" indent="-482138">
+            <a:pPr marL="882187" lvl="1" indent="-482137">
               <a:buAutoNum type="arabicPeriod"/>
               <a:defRPr/>
             </a:pPr>
@@ -3978,7 +3978,7 @@
             <a:endParaRPr sz="3600"/>
           </a:p>
           <a:p>
-            <a:pPr marL="882188" lvl="1" indent="-482138">
+            <a:pPr marL="882187" lvl="1" indent="-482137">
               <a:buAutoNum type="arabicPeriod"/>
               <a:defRPr/>
             </a:pPr>
@@ -3989,7 +3989,7 @@
             <a:endParaRPr sz="3600"/>
           </a:p>
           <a:p>
-            <a:pPr marL="482138" indent="-482138">
+            <a:pPr marL="482137" indent="-482137">
               <a:buAutoNum type="arabicPeriod"/>
               <a:defRPr/>
             </a:pPr>
@@ -4078,7 +4078,7 @@
             <a:endParaRPr sz="3600" b="1"/>
           </a:p>
           <a:p>
-            <a:pPr marL="482138" indent="-482138">
+            <a:pPr marL="482137" indent="-482137">
               <a:buAutoNum type="arabicPeriod"/>
               <a:defRPr/>
             </a:pPr>
@@ -4093,7 +4093,7 @@
             <a:endParaRPr sz="3600"/>
           </a:p>
           <a:p>
-            <a:pPr marL="482138" indent="-482138">
+            <a:pPr marL="482137" indent="-482137">
               <a:buAutoNum type="arabicPeriod"/>
               <a:defRPr/>
             </a:pPr>
@@ -4182,7 +4182,7 @@
             <a:endParaRPr sz="3600" b="1"/>
           </a:p>
           <a:p>
-            <a:pPr marL="482138" indent="-482138">
+            <a:pPr marL="482137" indent="-482137">
               <a:buAutoNum type="arabicPeriod"/>
               <a:defRPr/>
             </a:pPr>
@@ -4193,7 +4193,7 @@
             <a:endParaRPr sz="2800"/>
           </a:p>
           <a:p>
-            <a:pPr marL="482138" indent="-482138">
+            <a:pPr marL="482137" indent="-482137">
               <a:buAutoNum type="arabicPeriod"/>
               <a:defRPr/>
             </a:pPr>
@@ -4204,7 +4204,7 @@
             <a:endParaRPr sz="2800"/>
           </a:p>
           <a:p>
-            <a:pPr marL="482138" indent="-482138">
+            <a:pPr marL="482137" indent="-482137">
               <a:buAutoNum type="arabicPeriod"/>
               <a:defRPr/>
             </a:pPr>
@@ -4231,7 +4231,7 @@
         <p:spPr bwMode="auto">
           <a:xfrm flipH="0" flipV="0">
             <a:off x="321084" y="1026112"/>
-            <a:ext cx="5774915" cy="4711115"/>
+            <a:ext cx="5774915" cy="4711114"/>
           </a:xfrm>
           <a:prstGeom prst="rect">
             <a:avLst/>
@@ -4315,7 +4315,7 @@
             <a:endParaRPr sz="3600" b="1"/>
           </a:p>
           <a:p>
-            <a:pPr marL="482138" indent="-482138">
+            <a:pPr marL="482137" indent="-482137">
               <a:buAutoNum type="arabicPeriod"/>
               <a:defRPr/>
             </a:pPr>
@@ -4326,7 +4326,7 @@
             <a:endParaRPr sz="2800"/>
           </a:p>
           <a:p>
-            <a:pPr marL="482138" indent="-482138">
+            <a:pPr marL="482137" indent="-482137">
               <a:buAutoNum type="arabicPeriod"/>
               <a:defRPr/>
             </a:pPr>
@@ -4337,7 +4337,7 @@
             <a:endParaRPr sz="2800"/>
           </a:p>
           <a:p>
-            <a:pPr marL="482138" indent="-482138">
+            <a:pPr marL="482137" indent="-482137">
               <a:buAutoNum type="arabicPeriod"/>
               <a:defRPr/>
             </a:pPr>
@@ -4364,7 +4364,7 @@
         <p:spPr bwMode="auto">
           <a:xfrm flipH="0" flipV="0">
             <a:off x="321084" y="1026112"/>
-            <a:ext cx="5774915" cy="4711115"/>
+            <a:ext cx="5774915" cy="4711114"/>
           </a:xfrm>
           <a:prstGeom prst="rect">
             <a:avLst/>
@@ -4421,7 +4421,7 @@
         <p:spPr bwMode="auto">
           <a:xfrm rot="0" flipH="0" flipV="0">
             <a:off x="6544800" y="241200"/>
-            <a:ext cx="5439959" cy="4019905"/>
+            <a:ext cx="5439959" cy="4019904"/>
           </a:xfrm>
           <a:prstGeom prst="flowChartAlternateProcess">
             <a:avLst/>
@@ -4448,7 +4448,7 @@
             <a:endParaRPr sz="3600" b="1"/>
           </a:p>
           <a:p>
-            <a:pPr marL="482138" indent="-482138">
+            <a:pPr marL="482137" indent="-482137">
               <a:buAutoNum type="arabicPeriod"/>
               <a:defRPr/>
             </a:pPr>
@@ -4459,7 +4459,7 @@
             <a:endParaRPr sz="2800"/>
           </a:p>
           <a:p>
-            <a:pPr marL="482138" indent="-482138">
+            <a:pPr marL="482137" indent="-482137">
               <a:buAutoNum type="arabicPeriod"/>
               <a:defRPr/>
             </a:pPr>
@@ -4486,7 +4486,7 @@
         <p:spPr bwMode="auto">
           <a:xfrm flipH="0" flipV="0">
             <a:off x="321084" y="1026112"/>
-            <a:ext cx="5774915" cy="4711115"/>
+            <a:ext cx="5774915" cy="4711114"/>
           </a:xfrm>
           <a:prstGeom prst="rect">
             <a:avLst/>
@@ -4543,7 +4543,7 @@
         <p:spPr bwMode="auto">
           <a:xfrm rot="0" flipH="0" flipV="0">
             <a:off x="6544800" y="241200"/>
-            <a:ext cx="5401079" cy="4019905"/>
+            <a:ext cx="5401079" cy="4019904"/>
           </a:xfrm>
           <a:prstGeom prst="flowChartAlternateProcess">
             <a:avLst/>
@@ -4580,7 +4580,7 @@
             <a:endParaRPr sz="2800"/>
           </a:p>
           <a:p>
-            <a:pPr marL="482138" indent="-482138">
+            <a:pPr marL="482137" indent="-482137">
               <a:buAutoNum type="arabicPeriod"/>
               <a:defRPr/>
             </a:pPr>
@@ -4591,7 +4591,7 @@
             <a:endParaRPr sz="2800"/>
           </a:p>
           <a:p>
-            <a:pPr marL="482138" indent="-482138">
+            <a:pPr marL="482137" indent="-482137">
               <a:buAutoNum type="arabicPeriod"/>
               <a:defRPr/>
             </a:pPr>
@@ -4602,7 +4602,7 @@
             <a:endParaRPr sz="2800"/>
           </a:p>
           <a:p>
-            <a:pPr marL="482138" indent="-482138">
+            <a:pPr marL="482137" indent="-482137">
               <a:buAutoNum type="arabicPeriod"/>
               <a:defRPr/>
             </a:pPr>
@@ -4629,7 +4629,7 @@
         <p:spPr bwMode="auto">
           <a:xfrm flipH="0" flipV="0">
             <a:off x="321084" y="1026112"/>
-            <a:ext cx="5774915" cy="4711115"/>
+            <a:ext cx="5774915" cy="4711114"/>
           </a:xfrm>
           <a:prstGeom prst="rect">
             <a:avLst/>
@@ -4713,7 +4713,7 @@
             <a:endParaRPr sz="3600" b="1"/>
           </a:p>
           <a:p>
-            <a:pPr marL="482138" indent="-482138">
+            <a:pPr marL="482137" indent="-482137">
               <a:buAutoNum type="arabicPeriod"/>
               <a:defRPr/>
             </a:pPr>
@@ -4724,7 +4724,7 @@
             <a:endParaRPr sz="3600"/>
           </a:p>
           <a:p>
-            <a:pPr marL="482138" indent="-482138">
+            <a:pPr marL="482137" indent="-482137">
               <a:buAutoNum type="arabicPeriod"/>
               <a:defRPr/>
             </a:pPr>
@@ -4783,7 +4783,7 @@
             </a:endParaRPr>
           </a:p>
           <a:p>
-            <a:pPr marL="482138" indent="-482138">
+            <a:pPr marL="482137" indent="-482137">
               <a:buAutoNum type="arabicPeriod"/>
               <a:defRPr/>
             </a:pPr>
@@ -4810,7 +4810,7 @@
             </a:endParaRPr>
           </a:p>
           <a:p>
-            <a:pPr marL="482138" indent="-482138">
+            <a:pPr marL="482137" indent="-482137">
               <a:buAutoNum type="arabicPeriod"/>
               <a:defRPr/>
             </a:pPr>
@@ -4896,7 +4896,7 @@
         <p:spPr bwMode="auto">
           <a:xfrm rot="0" flipH="0" flipV="0">
             <a:off x="360000" y="360000"/>
-            <a:ext cx="11520360" cy="5573683"/>
+            <a:ext cx="11521799" cy="5573683"/>
           </a:xfrm>
           <a:prstGeom prst="flowChartAlternateProcess">
             <a:avLst/>
@@ -4923,7 +4923,7 @@
             <a:endParaRPr sz="3600" b="1"/>
           </a:p>
           <a:p>
-            <a:pPr marL="482138" indent="-482138">
+            <a:pPr marL="482137" indent="-482137">
               <a:buAutoNum type="arabicPeriod"/>
               <a:defRPr/>
             </a:pPr>
@@ -4934,7 +4934,7 @@
             <a:endParaRPr sz="3600"/>
           </a:p>
           <a:p>
-            <a:pPr marL="482138" indent="-482138">
+            <a:pPr marL="482137" indent="-482137">
               <a:buAutoNum type="arabicPeriod"/>
               <a:defRPr/>
             </a:pPr>
@@ -4945,7 +4945,7 @@
             <a:endParaRPr sz="3600"/>
           </a:p>
           <a:p>
-            <a:pPr marL="482138" indent="-482138">
+            <a:pPr marL="482137" indent="-482137">
               <a:buAutoNum type="arabicPeriod"/>
               <a:defRPr/>
             </a:pPr>
@@ -4956,7 +4956,7 @@
             <a:endParaRPr sz="3600"/>
           </a:p>
           <a:p>
-            <a:pPr marL="482138" indent="-482138">
+            <a:pPr marL="482137" indent="-482137">
               <a:buAutoNum type="arabicPeriod"/>
               <a:defRPr/>
             </a:pPr>
@@ -4967,7 +4967,7 @@
             <a:endParaRPr sz="3600"/>
           </a:p>
           <a:p>
-            <a:pPr marL="482138" indent="-482138">
+            <a:pPr marL="482137" indent="-482137">
               <a:buAutoNum type="arabicPeriod"/>
               <a:defRPr/>
             </a:pPr>
@@ -4978,7 +4978,7 @@
             <a:endParaRPr sz="3600"/>
           </a:p>
           <a:p>
-            <a:pPr marL="482138" indent="-482138">
+            <a:pPr marL="482137" indent="-482137">
               <a:buAutoNum type="arabicPeriod"/>
               <a:defRPr/>
             </a:pPr>
@@ -4989,7 +4989,7 @@
             <a:endParaRPr sz="3600"/>
           </a:p>
           <a:p>
-            <a:pPr marL="482138" indent="-482138">
+            <a:pPr marL="482137" indent="-482137">
               <a:buAutoNum type="arabicPeriod"/>
               <a:defRPr/>
             </a:pPr>

</xml_diff>